<commit_message>
feat(workshop): hernoem skills naar verkennen en bouwen, herschik workshop-rad
- skills workshop-verkennen/workshop-dashboard heten nu verkennen en bouwen
  (decks, docs en scripts bijgewerkt); bouwen kreeg regels voor korte
  grafiektitels en consistente labels
- antwoordsleutel naar data/antwoordsleutel/, zodat data/ veilig te delen is
- voorstel-deck alleen nog in workshop-rad/exports (root-kopie verwijderd,
  origineel blijft in commit 67272a3)
- decks en docs bijgewerkt: Sonnet 5.5, Claude-paneel, tweede tijdmeting
- uitvoeringsdeck: te volle dia's ingekort (0 waarschuwingen)

Co-Authored-By: Claude Sonnet 5.5 <noreply@anthropic.com>
</commit_message>
<xml_diff>
--- a/workshop-rad/exports/workshop-voorstel-RAD_120min.pptx
+++ b/workshop-rad/exports/workshop-voorstel-RAD_120min.pptx
@@ -4021,7 +4021,7 @@
                 <a:ea typeface="General Sans" pitchFamily="34" charset="-122"/>
                 <a:cs typeface="General Sans" pitchFamily="34" charset="-120"/>
               </a:rPr>
-              <a:t>/workshop-verkennen en /workshop-dashboard. Deelnemers prompten zelf; de leider draait de skills live (gemeten: ongeveer 1 en 2 tot 2,5 minuut). Vaste tussenproducten, kosten €0.</a:t>
+              <a:t>/verkennen en /bouwen. Deelnemers prompten zelf; de leider draait de skills live (gemeten: ongeveer 1 tot 2 en 2 tot 3 minuut). Vaste tussenproducten, kosten €0.</a:t>
             </a:r>
             <a:endParaRPr lang="en-US" sz="1300" dirty="0"/>
           </a:p>
@@ -5445,7 +5445,7 @@
                 <a:ea typeface="General Sans" pitchFamily="34" charset="-122"/>
                 <a:cs typeface="General Sans" pitchFamily="34" charset="-120"/>
               </a:rPr>
-              <a:t>Kanttekening devcontainer: deelnemers werken alleen via de AI-agent, in de Codespaces-omgeving dair-agentic-coding (Claude via Foundry). Python en uv staan erin; DuckDB, Streamlit en Plotly nog niet (voorstel: issue #10). Welk model deelnemers krijgen is nog open (issue #11).</a:t>
+              <a:t>Kanttekening devcontainer: deelnemers werken alleen via de AI-agent, in de Codespaces-omgeving dair-agentic-coding (Claude via Foundry). Python en uv staan erin; DuckDB, Streamlit en Plotly installeert de skill zelf met uv (voorstel: ze vooraf in het image zetten, issue #10). Deelnemers krijgen Claude Sonnet 5.5.</a:t>
             </a:r>
             <a:endParaRPr lang="en-US" sz="1400" dirty="0"/>
           </a:p>
@@ -6096,7 +6096,7 @@
                 <a:ea typeface="General Sans" pitchFamily="34" charset="-122"/>
                 <a:cs typeface="General Sans" pitchFamily="34" charset="-120"/>
               </a:rPr>
-              <a:t>Gemeten: ongeveer 1 en 2 tot 2,5 minuut, met een ander model dan in de devcontainer. Opnieuw meten in de echte omgeving en ruim marge nemen.</a:t>
+              <a:t>Gemeten met hetzelfde model als de deelnemers: 1 tot 2 minuut en 2 tot 3 minuut. Opnieuw meten in de echte omgeving en ruim marge nemen.</a:t>
             </a:r>
             <a:endParaRPr lang="en-US" sz="1150" dirty="0"/>
           </a:p>
@@ -7030,7 +7030,7 @@
                 <a:ea typeface="General Sans" pitchFamily="34" charset="-122"/>
                 <a:cs typeface="General Sans" pitchFamily="34" charset="-120"/>
               </a:rPr>
-              <a:t>Pakketten in het image (issue #10) en welk Claude-model deelnemers krijgen (issue #11), bij Tomer.</a:t>
+              <a:t>Pakketten vooraf in het image (issue #10), bij Tomer. Het model is Sonnet 5.5.</a:t>
             </a:r>
             <a:endParaRPr lang="en-US" sz="1300" dirty="0"/>
           </a:p>
@@ -7176,7 +7176,7 @@
                 <a:ea typeface="General Sans" pitchFamily="34" charset="-122"/>
                 <a:cs typeface="General Sans" pitchFamily="34" charset="-120"/>
               </a:rPr>
-              <a:t>De skills staan in een pull request (#9) en moeten nog gereviewd worden. De data volgt apart.</a:t>
+              <a:t>De skills en de synthetische data staan in dair-agentic-coding, nog te mergen naar main.</a:t>
             </a:r>
             <a:endParaRPr lang="en-US" sz="1300" dirty="0"/>
           </a:p>

</xml_diff>